<commit_message>
docs: readout deck v10, latest edits (2026-10-11 10:15)
Co-Authored-By: Claude Opus 5.5 <noreply@anthropic.com>
Claude-Session: https://claude.ai/code/session_017wYPadg1PUbXtrtuVf6oTy
</commit_message>
<xml_diff>
--- a/docs/Ami-L4-Readout-v10-2026-10-10.pptx
+++ b/docs/Ami-L4-Readout-v10-2026-10-10.pptx
@@ -604,11 +604,8 @@
           <a:lstStyle/>
           <a:p>
             <a:r>
-              <a:t>This </a:t>
-            </a:r>
-            <a:r>
               <a:rPr dirty="0"/>
-              <a:t>is our L4 readout on Ami, the support agent from class. We took it from a demo towards production against six goals, and measured every change before and after on the same frozen tests. Two slides on the product and the ask, then the numbers.</a:t>
+              <a:t>This is our L4 readout on Ami, the support agent from class. We took it from a demo towards production against six goals, and measured every change before and after on the same frozen tests. Two slides on the product and the ask, then the numbers.</a:t>
             </a:r>
           </a:p>
         </p:txBody>
@@ -1375,6 +1372,41 @@
             <a:r>
               <a:rPr dirty="0"/>
               <a:t>Third, what we need to go further. An endpoint that serves two models, so routing can be switched on and measured live. Prompt caching we can predict, to close the gap to the half-cost target. Order prefetch measured live. A nightly golden run behind the 0.90 alert. And the witnessed run on merged master, then sign-off. Everything here is reproducible from the repo. Questions?</a:t>
+            </a:r>
+          </a:p>
+          <a:p>
+            <a:endParaRPr dirty="0"/>
+          </a:p>
+          <a:p>
+            <a:r>
+              <a:rPr dirty="0"/>
+              <a:t>DETAILS BEHIND THE THREE BOXES</a:t>
+            </a:r>
+          </a:p>
+          <a:p>
+            <a:r>
+              <a:rPr dirty="0"/>
+              <a:t>Box 1, the two caveats. Cost: the brief asked for half; we reached −38% per golden run and −11% per turn, because most of each call is a prompt prefix the proxy caches unpredictably (cache hits swung 79% to 48% between identical runs). Routing: the router is built, unit-tested and verified live on 10 October (easy turns requested the cheap tier), but the class proxy serves gpt-5.6-terra whatever model is requested, so no live saving; 25% is the figure at list prices.</a:t>
+            </a:r>
+          </a:p>
+          <a:p>
+            <a:r>
+              <a:rPr dirty="0"/>
+              <a:t>Box 2, the other learnings. Test what the agent did (tools called, refusals, store state), not only what it said. Instrument before </a:t>
+            </a:r>
+            <a:r>
+              <a:rPr dirty="0" err="1"/>
+              <a:t>optimising</a:t>
+            </a:r>
+            <a:r>
+              <a:rPr dirty="0"/>
+              <a:t>: a dashboard with null fields hid regressions until the alerts and the break-on-purpose test existed. Review every PR: two of our six misses were caught in review, including the scope leak.</a:t>
+            </a:r>
+          </a:p>
+          <a:p>
+            <a:r>
+              <a:rPr dirty="0"/>
+              <a:t>Box 3, the other next steps in full. Order prefetch measured live for cost and latency together. Prompt caching made predictable so the half-cost target is reachable. The witnessed run on merged master, then the signed readout.</a:t>
             </a:r>
           </a:p>
         </p:txBody>
@@ -3416,12 +3448,20 @@
           </a:lstStyle>
           <a:p>
             <a:r>
-              <a:rPr sz="1600" dirty="0" err="1"/>
+              <a:rPr lang="en-US" sz="1600" dirty="0" err="1"/>
               <a:t>Thalanayar</a:t>
             </a:r>
             <a:r>
               <a:rPr sz="1600" dirty="0"/>
-              <a:t> Kumar </a:t>
+              <a:t> </a:t>
+            </a:r>
+            <a:r>
+              <a:rPr lang="en-US" sz="1600" dirty="0"/>
+              <a:t>Muthuk</a:t>
+            </a:r>
+            <a:r>
+              <a:rPr sz="1600" dirty="0"/>
+              <a:t>umar </a:t>
             </a:r>
             <a:endParaRPr lang="en-US" sz="1600" dirty="0"/>
           </a:p>
@@ -13041,15 +13081,7 @@
             </a:pPr>
             <a:r>
               <a:rPr lang="en-US" b="0" dirty="0"/>
-              <a:t>- No record </a:t>
-            </a:r>
-            <a:r>
-              <a:rPr lang="en-US" b="0" dirty="0" err="1"/>
-              <a:t>ofof</a:t>
-            </a:r>
-            <a:r>
-              <a:rPr lang="en-US" b="0" dirty="0"/>
-              <a:t> turn or cost</a:t>
+              <a:t>- No record of turn or cost</a:t>
             </a:r>
           </a:p>
         </p:txBody>
@@ -13132,13 +13164,13 @@
           <a:p>
             <a:r>
               <a:rPr lang="en-US" dirty="0"/>
-              <a:t>-Graceful handoff in 14 seconds</a:t>
+              <a:t>- Response time in 14 seconds</a:t>
             </a:r>
           </a:p>
           <a:p>
             <a:r>
               <a:rPr lang="en-US" dirty="0"/>
-              <a:t>-Observability and Evals in place. </a:t>
+              <a:t>- Observability and Evals in place. </a:t>
             </a:r>
           </a:p>
         </p:txBody>
@@ -18182,13 +18214,22 @@
           <a:p>
             <a:pPr algn="l"/>
             <a:r>
-              <a:rPr sz="1000" b="0" i="0">
+              <a:rPr sz="1000" b="0" i="0" dirty="0" err="1">
                 <a:solidFill>
                   <a:srgbClr val="6B6B6B"/>
                 </a:solidFill>
                 <a:latin typeface="Calibri"/>
               </a:rPr>
-              <a:t>Behavioural suite 15 → 17–20 of 20 · unit tests 251 pass, 46 fail → 346, 0 · same frozen suites, same judge · before = cd098e0, after = 858e9aa; ranges include the merged-master run 317632a</a:t>
+              <a:t>Behavioural</a:t>
+            </a:r>
+            <a:r>
+              <a:rPr sz="1000" b="0" i="0" dirty="0">
+                <a:solidFill>
+                  <a:srgbClr val="6B6B6B"/>
+                </a:solidFill>
+                <a:latin typeface="Calibri"/>
+              </a:rPr>
+              <a:t> suite 15 → 17–20 of 20 · unit tests 251 pass, 46 fail → 346, 0 · same frozen suites, same judge · before = cd098e0, after = 858e9aa; ranges include the merged-master run 317632a</a:t>
             </a:r>
           </a:p>
         </p:txBody>
@@ -18234,6 +18275,7 @@
           <a:lstStyle/>
           <a:p>
             <a:pPr algn="ctr"/>
+            <a:endParaRPr/>
           </a:p>
         </p:txBody>
       </p:sp>
@@ -18305,6 +18347,7 @@
           <a:lstStyle/>
           <a:p>
             <a:pPr algn="ctr"/>
+            <a:endParaRPr/>
           </a:p>
         </p:txBody>
       </p:sp>
@@ -18349,6 +18392,7 @@
           <a:lstStyle/>
           <a:p>
             <a:pPr algn="ctr"/>
+            <a:endParaRPr/>
           </a:p>
         </p:txBody>
       </p:sp>
@@ -18420,6 +18464,7 @@
           <a:lstStyle/>
           <a:p>
             <a:pPr algn="ctr"/>
+            <a:endParaRPr/>
           </a:p>
         </p:txBody>
       </p:sp>
@@ -18464,6 +18509,7 @@
           <a:lstStyle/>
           <a:p>
             <a:pPr algn="ctr"/>
+            <a:endParaRPr/>
           </a:p>
         </p:txBody>
       </p:sp>
@@ -18535,6 +18581,7 @@
           <a:lstStyle/>
           <a:p>
             <a:pPr algn="ctr"/>
+            <a:endParaRPr/>
           </a:p>
         </p:txBody>
       </p:sp>
@@ -18579,6 +18626,7 @@
           <a:lstStyle/>
           <a:p>
             <a:pPr algn="ctr"/>
+            <a:endParaRPr/>
           </a:p>
         </p:txBody>
       </p:sp>
@@ -18650,6 +18698,7 @@
           <a:lstStyle/>
           <a:p>
             <a:pPr algn="ctr"/>
+            <a:endParaRPr/>
           </a:p>
         </p:txBody>
       </p:sp>
@@ -18694,6 +18743,7 @@
           <a:lstStyle/>
           <a:p>
             <a:pPr algn="ctr"/>
+            <a:endParaRPr/>
           </a:p>
         </p:txBody>
       </p:sp>
@@ -18765,6 +18815,7 @@
           <a:lstStyle/>
           <a:p>
             <a:pPr algn="ctr"/>
+            <a:endParaRPr/>
           </a:p>
         </p:txBody>
       </p:sp>
@@ -18809,6 +18860,7 @@
           <a:lstStyle/>
           <a:p>
             <a:pPr algn="ctr"/>
+            <a:endParaRPr/>
           </a:p>
         </p:txBody>
       </p:sp>
@@ -18880,6 +18932,7 @@
           <a:lstStyle/>
           <a:p>
             <a:pPr algn="ctr"/>
+            <a:endParaRPr/>
           </a:p>
         </p:txBody>
       </p:sp>
@@ -21767,8 +21820,6 @@
       <p:bldP spid="14" grpId="0" animBg="1"/>
       <p:bldP spid="15" grpId="0" animBg="1"/>
       <p:bldP spid="16" grpId="0" animBg="1"/>
-      <p:bldP spid="249" grpId="0" animBg="1"/>
-      <p:bldP spid="250" grpId="0" animBg="1"/>
       <p:bldP spid="19" grpId="0" animBg="1"/>
       <p:bldP spid="20" grpId="0" animBg="1"/>
       <p:bldP spid="21" grpId="0" animBg="1"/>
@@ -21780,8 +21831,6 @@
       <p:bldP spid="27" grpId="0" animBg="1"/>
       <p:bldP spid="28" grpId="0" animBg="1"/>
       <p:bldP spid="29" grpId="0" animBg="1"/>
-      <p:bldP spid="251" grpId="0" animBg="1"/>
-      <p:bldP spid="252" grpId="0" animBg="1"/>
       <p:bldP spid="32" grpId="0" animBg="1"/>
       <p:bldP spid="33" grpId="0" animBg="1"/>
       <p:bldP spid="34" grpId="0" animBg="1"/>
@@ -21793,8 +21842,6 @@
       <p:bldP spid="40" grpId="0" animBg="1"/>
       <p:bldP spid="41" grpId="0" animBg="1"/>
       <p:bldP spid="42" grpId="0" animBg="1"/>
-      <p:bldP spid="253" grpId="0" animBg="1"/>
-      <p:bldP spid="254" grpId="0" animBg="1"/>
       <p:bldP spid="45" grpId="0" animBg="1"/>
       <p:bldP spid="46" grpId="0" animBg="1"/>
       <p:bldP spid="47" grpId="0" animBg="1"/>
@@ -21806,8 +21853,6 @@
       <p:bldP spid="53" grpId="0" animBg="1"/>
       <p:bldP spid="54" grpId="0" animBg="1"/>
       <p:bldP spid="55" grpId="0" animBg="1"/>
-      <p:bldP spid="255" grpId="0" animBg="1"/>
-      <p:bldP spid="256" grpId="0" animBg="1"/>
       <p:bldP spid="58" grpId="0" animBg="1"/>
       <p:bldP spid="59" grpId="0" animBg="1"/>
       <p:bldP spid="60" grpId="0" animBg="1"/>
@@ -21819,8 +21864,6 @@
       <p:bldP spid="66" grpId="0" animBg="1"/>
       <p:bldP spid="67" grpId="0" animBg="1"/>
       <p:bldP spid="68" grpId="0" animBg="1"/>
-      <p:bldP spid="257" grpId="0" animBg="1"/>
-      <p:bldP spid="258" grpId="0" animBg="1"/>
       <p:bldP spid="71" grpId="0" animBg="1"/>
       <p:bldP spid="72" grpId="0" animBg="1"/>
       <p:bldP spid="73" grpId="0" animBg="1"/>
@@ -21832,6 +21875,16 @@
       <p:bldP spid="79" grpId="0" animBg="1"/>
       <p:bldP spid="80" grpId="0" animBg="1"/>
       <p:bldP spid="81" grpId="0" animBg="1"/>
+      <p:bldP spid="249" grpId="0" animBg="1"/>
+      <p:bldP spid="250" grpId="0" animBg="1"/>
+      <p:bldP spid="251" grpId="0" animBg="1"/>
+      <p:bldP spid="252" grpId="0" animBg="1"/>
+      <p:bldP spid="253" grpId="0" animBg="1"/>
+      <p:bldP spid="254" grpId="0" animBg="1"/>
+      <p:bldP spid="255" grpId="0" animBg="1"/>
+      <p:bldP spid="256" grpId="0" animBg="1"/>
+      <p:bldP spid="257" grpId="0" animBg="1"/>
+      <p:bldP spid="258" grpId="0" animBg="1"/>
       <p:bldP spid="259" grpId="0" animBg="1"/>
       <p:bldP spid="260" grpId="0" animBg="1"/>
     </p:bldLst>
@@ -22164,7 +22217,7 @@
         <p:spPr>
           <a:xfrm>
             <a:off x="914400" y="3364991"/>
-            <a:ext cx="2930042" cy="1554480"/>
+            <a:ext cx="2930042" cy="892552"/>
           </a:xfrm>
           <a:prstGeom prst="rect">
             <a:avLst/>
@@ -22177,84 +22230,43 @@
           </a:bodyPr>
           <a:lstStyle/>
           <a:p>
-            <a:pPr algn="l">
+            <a:pPr>
               <a:spcAft>
-                <a:spcPts val="300"/>
+                <a:spcPts val="600"/>
               </a:spcAft>
             </a:pPr>
             <a:r>
-              <a:rPr sz="1050" b="0" i="0">
-                <a:solidFill>
-                  <a:srgbClr val="1A1A1A"/>
-                </a:solidFill>
-                <a:latin typeface="Calibri"/>
-              </a:rPr>
-              <a:t>•  Cost −38% per run, p95 −30%</a:t>
-            </a:r>
-          </a:p>
-          <a:p>
-            <a:pPr algn="l">
+              <a:rPr lang="en-US" sz="1200" dirty="0"/>
+              <a:t> •  All six goals met on the frozen suites                                                                                  </a:t>
+            </a:r>
+          </a:p>
+          <a:p>
+            <a:pPr>
               <a:spcAft>
-                <a:spcPts val="300"/>
+                <a:spcPts val="600"/>
               </a:spcAft>
             </a:pPr>
             <a:r>
-              <a:rPr sz="1050" b="0" i="0">
-                <a:solidFill>
-                  <a:srgbClr val="1A1A1A"/>
-                </a:solidFill>
-                <a:latin typeface="Calibri"/>
-              </a:rPr>
-              <a:t>•  10/10 complaints pass, golden 0.81 → 0.91–0.97</a:t>
-            </a:r>
-          </a:p>
-          <a:p>
-            <a:pPr algn="l">
+              <a:rPr lang="en-US" sz="1200" dirty="0"/>
+              <a:t>  •  Cost: 38%  saving against 50% per run                                                                                   </a:t>
+            </a:r>
+          </a:p>
+          <a:p>
+            <a:pPr>
               <a:spcAft>
-                <a:spcPts val="300"/>
+                <a:spcPts val="600"/>
               </a:spcAft>
             </a:pPr>
             <a:r>
-              <a:rPr sz="1050" b="0" i="0">
-                <a:solidFill>
-                  <a:srgbClr val="1A1A1A"/>
-                </a:solidFill>
-                <a:latin typeface="Calibri"/>
-              </a:rPr>
-              <a:t>•  Injection: 14-min hang → 13 s hand-off</a:t>
-            </a:r>
-          </a:p>
-          <a:p>
-            <a:pPr algn="l">
-              <a:spcAft>
-                <a:spcPts val="300"/>
-              </a:spcAft>
-            </a:pPr>
-            <a:r>
-              <a:rPr sz="1050" b="0" i="0">
-                <a:solidFill>
-                  <a:srgbClr val="1A1A1A"/>
-                </a:solidFill>
-                <a:latin typeface="Calibri"/>
-              </a:rPr>
-              <a:t>•  Login + isolation verified live</a:t>
-            </a:r>
-          </a:p>
-          <a:p>
-            <a:pPr algn="l">
-              <a:spcAft>
-                <a:spcPts val="300"/>
-              </a:spcAft>
-            </a:pPr>
-            <a:r>
-              <a:rPr sz="1050" b="0" i="0">
-                <a:solidFill>
-                  <a:srgbClr val="1A1A1A"/>
-                </a:solidFill>
-                <a:latin typeface="Calibri"/>
-              </a:rPr>
-              <a:t>•  Router built, −25% at list prices</a:t>
-            </a:r>
+              <a:rPr lang="en-US" sz="1200" dirty="0"/>
+              <a:t>  •  Model routing built, not live due to proxy settings</a:t>
+            </a:r>
+            <a:endParaRPr sz="1200" dirty="0">
+              <a:solidFill>
+                <a:srgbClr val="1A1A1A"/>
+              </a:solidFill>
+              <a:latin typeface="Calibri"/>
+            </a:endParaRPr>
           </a:p>
         </p:txBody>
       </p:sp>
@@ -22419,7 +22431,7 @@
         <p:spPr>
           <a:xfrm>
             <a:off x="4630826" y="3364991"/>
-            <a:ext cx="2930042" cy="1554480"/>
+            <a:ext cx="2930042" cy="1261884"/>
           </a:xfrm>
           <a:prstGeom prst="rect">
             <a:avLst/>
@@ -22434,98 +22446,82 @@
           <a:p>
             <a:pPr algn="l">
               <a:spcAft>
-                <a:spcPts val="300"/>
+                <a:spcPts val="600"/>
               </a:spcAft>
             </a:pPr>
             <a:r>
-              <a:rPr sz="1050" b="0" i="0">
+              <a:rPr sz="1200" b="0" i="0" dirty="0">
                 <a:solidFill>
                   <a:srgbClr val="1A1A1A"/>
                 </a:solidFill>
                 <a:latin typeface="Calibri"/>
               </a:rPr>
-              <a:t>•  Freeze the tests first, measure on them</a:t>
-            </a:r>
-          </a:p>
-          <a:p>
-            <a:pPr algn="l">
+              <a:t>•  Freeze the tests first, measure every change on them</a:t>
+            </a:r>
+          </a:p>
+          <a:p>
+            <a:pPr>
               <a:spcAft>
-                <a:spcPts val="300"/>
+                <a:spcPts val="600"/>
               </a:spcAft>
             </a:pPr>
             <a:r>
-              <a:rPr sz="1050" b="0" i="0">
+              <a:rPr sz="1200" dirty="0">
                 <a:solidFill>
                   <a:srgbClr val="1A1A1A"/>
                 </a:solidFill>
                 <a:latin typeface="Calibri"/>
               </a:rPr>
-              <a:t>•  Test what the agent did, not only what it said</a:t>
-            </a:r>
-          </a:p>
-          <a:p>
-            <a:pPr algn="l">
-              <a:spcAft>
-                <a:spcPts val="300"/>
-              </a:spcAft>
-            </a:pPr>
-            <a:r>
-              <a:rPr sz="1050" b="0" i="0">
+              <a:t>•  </a:t>
+            </a:r>
+            <a:r>
+              <a:rPr lang="en-US" sz="1200" dirty="0">
                 <a:solidFill>
                   <a:srgbClr val="1A1A1A"/>
                 </a:solidFill>
                 <a:latin typeface="Calibri"/>
               </a:rPr>
-              <a:t>•  Scope from the session, never from the model</a:t>
-            </a:r>
-          </a:p>
-          <a:p>
-            <a:pPr algn="l">
+              <a:t>T</a:t>
+            </a:r>
+            <a:r>
+              <a:rPr lang="en-US" sz="1200" dirty="0"/>
+              <a:t>reat the model's output as input, not as fact</a:t>
+            </a:r>
+          </a:p>
+          <a:p>
+            <a:pPr>
               <a:spcAft>
-                <a:spcPts val="300"/>
+                <a:spcPts val="600"/>
               </a:spcAft>
             </a:pPr>
             <a:r>
-              <a:rPr sz="1050" b="0" i="0">
+              <a:rPr sz="1200" dirty="0">
                 <a:solidFill>
                   <a:srgbClr val="1A1A1A"/>
                 </a:solidFill>
                 <a:latin typeface="Calibri"/>
               </a:rPr>
-              <a:t>•  Own the retries; SDK retries hid a 14-min hang</a:t>
-            </a:r>
-          </a:p>
-          <a:p>
-            <a:pPr algn="l">
-              <a:spcAft>
-                <a:spcPts val="300"/>
-              </a:spcAft>
-            </a:pPr>
-            <a:r>
-              <a:rPr sz="1050" b="0" i="0">
+              <a:t>•  </a:t>
+            </a:r>
+            <a:r>
+              <a:rPr lang="en-US" sz="1200" dirty="0">
                 <a:solidFill>
                   <a:srgbClr val="1A1A1A"/>
                 </a:solidFill>
                 <a:latin typeface="Calibri"/>
               </a:rPr>
-              <a:t>•  Instrument before optimising; nulls hide bugs</a:t>
-            </a:r>
-          </a:p>
-          <a:p>
-            <a:pPr algn="l">
-              <a:spcAft>
-                <a:spcPts val="300"/>
-              </a:spcAft>
-            </a:pPr>
-            <a:r>
-              <a:rPr sz="1050" b="0" i="0">
-                <a:solidFill>
-                  <a:srgbClr val="1A1A1A"/>
-                </a:solidFill>
-                <a:latin typeface="Calibri"/>
-              </a:rPr>
-              <a:t>•  Review every PR; 2 of 6 misses caught there</a:t>
-            </a:r>
+              <a:t>K</a:t>
+            </a:r>
+            <a:r>
+              <a:rPr lang="en-US" sz="1200" dirty="0"/>
+              <a:t>now every place a retry or timeout lives, and make sure  there is only one</a:t>
+            </a:r>
+            <a:endParaRPr sz="1200" dirty="0">
+              <a:solidFill>
+                <a:srgbClr val="1A1A1A"/>
+              </a:solidFill>
+              <a:latin typeface="Calibri"/>
+            </a:endParaRPr>
           </a:p>
         </p:txBody>
       </p:sp>
@@ -22690,7 +22686,7 @@
         <p:spPr>
           <a:xfrm>
             <a:off x="8347252" y="3364991"/>
-            <a:ext cx="2930042" cy="1554480"/>
+            <a:ext cx="2930042" cy="1077218"/>
           </a:xfrm>
           <a:prstGeom prst="rect">
             <a:avLst/>
@@ -22705,81 +22701,86 @@
           <a:p>
             <a:pPr algn="l">
               <a:spcAft>
-                <a:spcPts val="300"/>
+                <a:spcPts val="600"/>
               </a:spcAft>
             </a:pPr>
             <a:r>
-              <a:rPr sz="1050" b="0" i="0">
+              <a:rPr sz="1200" b="0" i="0" dirty="0">
                 <a:solidFill>
                   <a:srgbClr val="1A1A1A"/>
                 </a:solidFill>
                 <a:latin typeface="Calibri"/>
               </a:rPr>
-              <a:t>•  Two-model endpoint: switch routing on, measure</a:t>
-            </a:r>
-          </a:p>
-          <a:p>
-            <a:pPr algn="l">
-              <a:spcAft>
-                <a:spcPts val="300"/>
-              </a:spcAft>
-            </a:pPr>
-            <a:r>
-              <a:rPr sz="1050" b="0" i="0">
+              <a:t>•  </a:t>
+            </a:r>
+            <a:r>
+              <a:rPr lang="en-US" sz="1200" b="0" i="0" dirty="0">
                 <a:solidFill>
                   <a:srgbClr val="1A1A1A"/>
                 </a:solidFill>
                 <a:latin typeface="Calibri"/>
               </a:rPr>
-              <a:t>•  Predictable prompt caching to reach half cost</a:t>
-            </a:r>
-          </a:p>
-          <a:p>
-            <a:pPr algn="l">
-              <a:spcAft>
-                <a:spcPts val="300"/>
-              </a:spcAft>
-            </a:pPr>
-            <a:r>
-              <a:rPr sz="1050" b="0" i="0">
+              <a:t>Enable </a:t>
+            </a:r>
+            <a:r>
+              <a:rPr sz="1200" b="0" i="0" dirty="0">
                 <a:solidFill>
                   <a:srgbClr val="1A1A1A"/>
                 </a:solidFill>
                 <a:latin typeface="Calibri"/>
               </a:rPr>
-              <a:t>•  Order prefetch measured live, cost and latency</a:t>
-            </a:r>
-          </a:p>
-          <a:p>
-            <a:pPr algn="l">
-              <a:spcAft>
-                <a:spcPts val="300"/>
-              </a:spcAft>
-            </a:pPr>
-            <a:r>
-              <a:rPr sz="1050" b="0" i="0">
+              <a:t>Two-model endpoint</a:t>
+            </a:r>
+            <a:r>
+              <a:rPr lang="en-US" sz="1200" b="0" i="0" dirty="0">
                 <a:solidFill>
                   <a:srgbClr val="1A1A1A"/>
                 </a:solidFill>
                 <a:latin typeface="Calibri"/>
               </a:rPr>
-              <a:t>•  Nightly golden run behind the 0.90 alert</a:t>
-            </a:r>
-          </a:p>
-          <a:p>
-            <a:pPr algn="l">
+              <a:t> at proxy for further saving cost </a:t>
+            </a:r>
+            <a:endParaRPr sz="1200" b="0" i="0" dirty="0">
+              <a:solidFill>
+                <a:srgbClr val="1A1A1A"/>
+              </a:solidFill>
+              <a:latin typeface="Calibri"/>
+            </a:endParaRPr>
+          </a:p>
+          <a:p>
+            <a:pPr>
               <a:spcAft>
-                <a:spcPts val="300"/>
+                <a:spcPts val="600"/>
               </a:spcAft>
             </a:pPr>
             <a:r>
-              <a:rPr sz="1050" b="0" i="0">
+              <a:rPr sz="1200" dirty="0">
                 <a:solidFill>
                   <a:srgbClr val="1A1A1A"/>
                 </a:solidFill>
                 <a:latin typeface="Calibri"/>
               </a:rPr>
-              <a:t>•  Witnessed run on merged master, then sign-off</a:t>
+              <a:t>•  </a:t>
+            </a:r>
+            <a:r>
+              <a:rPr lang="en-US" sz="1200" dirty="0"/>
+              <a:t>Make proxy prompt caching consistent </a:t>
+            </a:r>
+          </a:p>
+          <a:p>
+            <a:pPr>
+              <a:spcAft>
+                <a:spcPts val="600"/>
+              </a:spcAft>
+            </a:pPr>
+            <a:r>
+              <a:rPr sz="1200" dirty="0">
+                <a:solidFill>
+                  <a:srgbClr val="1A1A1A"/>
+                </a:solidFill>
+                <a:latin typeface="Calibri"/>
+              </a:rPr>
+              <a:t>•  Nightly golden run behind the 0.90 alert, then sign-off</a:t>
             </a:r>
           </a:p>
         </p:txBody>
@@ -22840,7 +22841,7 @@
         <p:spPr>
           <a:xfrm>
             <a:off x="932688" y="5367528"/>
-            <a:ext cx="10326319" cy="530352"/>
+            <a:ext cx="10326319" cy="353943"/>
           </a:xfrm>
           <a:prstGeom prst="rect">
             <a:avLst/>
@@ -22855,26 +22856,62 @@
           <a:p>
             <a:pPr algn="l"/>
             <a:r>
-              <a:rPr sz="1150" b="0" i="0">
+              <a:rPr sz="1150" b="0" i="0" dirty="0">
                 <a:solidFill>
                   <a:srgbClr val="1A1A1A"/>
                 </a:solidFill>
                 <a:latin typeface="Calibri"/>
               </a:rPr>
-              <a:t>Code and readout: github.com/barusr9/aurex-ami · PR #2 merged 8 October</a:t>
-            </a:r>
-          </a:p>
-          <a:p>
-            <a:pPr algn="l"/>
-            <a:r>
-              <a:rPr sz="1150" b="0" i="0">
+              <a:t>Code and readout: </a:t>
+            </a:r>
+            <a:r>
+              <a:rPr sz="1150" b="0" i="0" dirty="0" err="1">
                 <a:solidFill>
                   <a:srgbClr val="1A1A1A"/>
                 </a:solidFill>
                 <a:latin typeface="Calibri"/>
               </a:rPr>
-              <a:t>Plan, logs, evidence and a code snapshot: github.com/shreenathacc22/ami-l4-project</a:t>
-            </a:r>
+              <a:t>github.com</a:t>
+            </a:r>
+            <a:r>
+              <a:rPr sz="1150" b="0" i="0" dirty="0">
+                <a:solidFill>
+                  <a:srgbClr val="1A1A1A"/>
+                </a:solidFill>
+                <a:latin typeface="Calibri"/>
+              </a:rPr>
+              <a:t>/barusr9/</a:t>
+            </a:r>
+            <a:r>
+              <a:rPr sz="1150" b="0" i="0" dirty="0" err="1">
+                <a:solidFill>
+                  <a:srgbClr val="1A1A1A"/>
+                </a:solidFill>
+                <a:latin typeface="Calibri"/>
+              </a:rPr>
+              <a:t>aurex-ami</a:t>
+            </a:r>
+            <a:r>
+              <a:rPr sz="1150" b="0" i="0" dirty="0">
+                <a:solidFill>
+                  <a:srgbClr val="1A1A1A"/>
+                </a:solidFill>
+                <a:latin typeface="Calibri"/>
+              </a:rPr>
+              <a:t> · PR #2 merged 8 October</a:t>
+            </a:r>
+          </a:p>
+          <a:p>
+            <a:r>
+              <a:rPr lang="en-US" sz="1150" dirty="0"/>
+              <a:t>Live at :  https://aurex-ami-ami-78d2.vercel.app</a:t>
+            </a:r>
+            <a:endParaRPr sz="1150" b="0" i="0" dirty="0">
+              <a:solidFill>
+                <a:srgbClr val="1A1A1A"/>
+              </a:solidFill>
+              <a:latin typeface="Calibri"/>
+            </a:endParaRPr>
           </a:p>
         </p:txBody>
       </p:sp>

</xml_diff>